<commit_message>
docs: update team name credit to 'TheOne' on website and presentation slides
</commit_message>
<xml_diff>
--- a/redrob_ranker_deck.pptx
+++ b/redrob_ranker_deck.pptx
@@ -3233,7 +3233,7 @@
               </a:defRPr>
             </a:pPr>
             <a:r>
-              <a:t>Redrob Hackathon 2026 | Team Antigravity</a:t>
+              <a:t>Redrob Hackathon 2026 | TheOne</a:t>
             </a:r>
           </a:p>
         </p:txBody>
@@ -3363,7 +3363,7 @@
               </a:defRPr>
             </a:pPr>
             <a:r>
-              <a:t>Team Antigravity</a:t>
+              <a:t>TheOne</a:t>
             </a:r>
           </a:p>
         </p:txBody>

</xml_diff>